<commit_message>
Fix stale-session 'Audit not found': persistent demo DB + session validity check; add History page, clear chat, sign-up polish; deck updated
Co-Authored-By: Claude Sonnet 5.5 <noreply@anthropic.com>
</commit_message>
<xml_diff>
--- a/AuditPilot_IT2_Presentation.pptx
+++ b/AuditPilot_IT2_Presentation.pptx
@@ -608,7 +608,7 @@
           </a:p>
           <a:p>
             <a:r>
-              <a:t>Testing mein 79 tests hain aur sab pass hote hain: 19 checker aur scoring, 21 SSRF, 10 API aur auth, 18 agent, 8 nayi features ke (render, schedule, short refs), aur 3 MCP ke.</a:t>
+              <a:t>Testing mein 86 tests hain aur sab pass hote hain: 19 checker aur scoring, 21 SSRF, 10 API aur auth, 18 agent, 8 nayi features ke (render, schedule, short refs), 7 history aur sign-in ke, aur 3 MCP ke.</a:t>
             </a:r>
           </a:p>
           <a:p>
@@ -1033,7 +1033,7 @@
           </a:p>
           <a:p>
             <a:r>
-              <a:t>MCP SDK se same tools Claude Code mein bhi chalte hain, aur Vitest se 79 tests likhe hain.</a:t>
+              <a:t>MCP SDK se same tools Claude Code mein bhi chalte hain, aur Vitest se 86 tests likhe hain.</a:t>
             </a:r>
           </a:p>
         </p:txBody>
@@ -1373,7 +1373,7 @@
           </a:p>
           <a:p>
             <a:r>
-              <a:t>Neeche paanch modules hain: audit engine, AI summary aur chat, compare aur trend, scheduled audits, aur JavaScript rendering.</a:t>
+              <a:t>Neeche chhe modules hain: audit engine, AI summary aur chat, compare aur trend, history aur sign-in, scheduled audits, aur JavaScript rendering.</a:t>
             </a:r>
           </a:p>
         </p:txBody>
@@ -6056,7 +6056,7 @@
                 </a:solidFill>
                 <a:latin typeface="Segoe UI Semibold"/>
               </a:rPr>
-              <a:t>79 / 79</a:t>
+              <a:t>86 / 86</a:t>
             </a:r>
           </a:p>
         </p:txBody>
@@ -6156,8 +6156,8 @@
         </p:nvSpPr>
         <p:spPr>
           <a:xfrm>
-            <a:off x="6766560" y="3730752"/>
-            <a:ext cx="365760" cy="365760"/>
+            <a:off x="6766560" y="3703320"/>
+            <a:ext cx="365760" cy="329184"/>
           </a:xfrm>
           <a:prstGeom prst="rect">
             <a:avLst/>
@@ -6176,7 +6176,7 @@
               </a:lnSpc>
             </a:pPr>
             <a:r>
-              <a:rPr sz="1400" b="0">
+              <a:rPr sz="1300" b="0">
                 <a:solidFill>
                   <a:srgbClr val="059669"/>
                 </a:solidFill>
@@ -6195,8 +6195,8 @@
         </p:nvSpPr>
         <p:spPr>
           <a:xfrm>
-            <a:off x="7132320" y="3730752"/>
-            <a:ext cx="3474720" cy="365760"/>
+            <a:off x="7132320" y="3703320"/>
+            <a:ext cx="3474720" cy="329184"/>
           </a:xfrm>
           <a:prstGeom prst="rect">
             <a:avLst/>
@@ -6215,7 +6215,7 @@
               </a:lnSpc>
             </a:pPr>
             <a:r>
-              <a:rPr sz="1250" b="0">
+              <a:rPr sz="1200" b="0">
                 <a:solidFill>
                   <a:srgbClr val="1C1736"/>
                 </a:solidFill>
@@ -6234,8 +6234,8 @@
         </p:nvSpPr>
         <p:spPr>
           <a:xfrm>
-            <a:off x="10607040" y="3730752"/>
-            <a:ext cx="777240" cy="365760"/>
+            <a:off x="10607040" y="3703320"/>
+            <a:ext cx="777240" cy="329184"/>
           </a:xfrm>
           <a:prstGeom prst="rect">
             <a:avLst/>
@@ -6254,7 +6254,7 @@
               </a:lnSpc>
             </a:pPr>
             <a:r>
-              <a:rPr sz="1400" b="0">
+              <a:rPr sz="1300" b="0">
                 <a:solidFill>
                   <a:srgbClr val="6D28D9"/>
                 </a:solidFill>
@@ -6273,8 +6273,8 @@
         </p:nvSpPr>
         <p:spPr>
           <a:xfrm>
-            <a:off x="6766560" y="4123944"/>
-            <a:ext cx="365760" cy="365760"/>
+            <a:off x="6766560" y="4041648"/>
+            <a:ext cx="365760" cy="329184"/>
           </a:xfrm>
           <a:prstGeom prst="rect">
             <a:avLst/>
@@ -6293,7 +6293,7 @@
               </a:lnSpc>
             </a:pPr>
             <a:r>
-              <a:rPr sz="1400" b="0">
+              <a:rPr sz="1300" b="0">
                 <a:solidFill>
                   <a:srgbClr val="059669"/>
                 </a:solidFill>
@@ -6312,8 +6312,8 @@
         </p:nvSpPr>
         <p:spPr>
           <a:xfrm>
-            <a:off x="7132320" y="4123944"/>
-            <a:ext cx="3474720" cy="365760"/>
+            <a:off x="7132320" y="4041648"/>
+            <a:ext cx="3474720" cy="329184"/>
           </a:xfrm>
           <a:prstGeom prst="rect">
             <a:avLst/>
@@ -6332,7 +6332,7 @@
               </a:lnSpc>
             </a:pPr>
             <a:r>
-              <a:rPr sz="1250" b="0">
+              <a:rPr sz="1200" b="0">
                 <a:solidFill>
                   <a:srgbClr val="1C1736"/>
                 </a:solidFill>
@@ -6351,8 +6351,8 @@
         </p:nvSpPr>
         <p:spPr>
           <a:xfrm>
-            <a:off x="10607040" y="4123944"/>
-            <a:ext cx="777240" cy="365760"/>
+            <a:off x="10607040" y="4041648"/>
+            <a:ext cx="777240" cy="329184"/>
           </a:xfrm>
           <a:prstGeom prst="rect">
             <a:avLst/>
@@ -6371,7 +6371,7 @@
               </a:lnSpc>
             </a:pPr>
             <a:r>
-              <a:rPr sz="1400" b="0">
+              <a:rPr sz="1300" b="0">
                 <a:solidFill>
                   <a:srgbClr val="6D28D9"/>
                 </a:solidFill>
@@ -6390,8 +6390,8 @@
         </p:nvSpPr>
         <p:spPr>
           <a:xfrm>
-            <a:off x="6766560" y="4517136"/>
-            <a:ext cx="365760" cy="365760"/>
+            <a:off x="6766560" y="4379976"/>
+            <a:ext cx="365760" cy="329184"/>
           </a:xfrm>
           <a:prstGeom prst="rect">
             <a:avLst/>
@@ -6410,7 +6410,7 @@
               </a:lnSpc>
             </a:pPr>
             <a:r>
-              <a:rPr sz="1400" b="0">
+              <a:rPr sz="1300" b="0">
                 <a:solidFill>
                   <a:srgbClr val="059669"/>
                 </a:solidFill>
@@ -6429,8 +6429,8 @@
         </p:nvSpPr>
         <p:spPr>
           <a:xfrm>
-            <a:off x="7132320" y="4517136"/>
-            <a:ext cx="3474720" cy="365760"/>
+            <a:off x="7132320" y="4379976"/>
+            <a:ext cx="3474720" cy="329184"/>
           </a:xfrm>
           <a:prstGeom prst="rect">
             <a:avLst/>
@@ -6449,7 +6449,7 @@
               </a:lnSpc>
             </a:pPr>
             <a:r>
-              <a:rPr sz="1250" b="0">
+              <a:rPr sz="1200" b="0">
                 <a:solidFill>
                   <a:srgbClr val="1C1736"/>
                 </a:solidFill>
@@ -6468,8 +6468,8 @@
         </p:nvSpPr>
         <p:spPr>
           <a:xfrm>
-            <a:off x="10607040" y="4517136"/>
-            <a:ext cx="777240" cy="365760"/>
+            <a:off x="10607040" y="4379976"/>
+            <a:ext cx="777240" cy="329184"/>
           </a:xfrm>
           <a:prstGeom prst="rect">
             <a:avLst/>
@@ -6488,7 +6488,7 @@
               </a:lnSpc>
             </a:pPr>
             <a:r>
-              <a:rPr sz="1400" b="0">
+              <a:rPr sz="1300" b="0">
                 <a:solidFill>
                   <a:srgbClr val="6D28D9"/>
                 </a:solidFill>
@@ -6507,8 +6507,8 @@
         </p:nvSpPr>
         <p:spPr>
           <a:xfrm>
-            <a:off x="6766560" y="4910328"/>
-            <a:ext cx="365760" cy="365760"/>
+            <a:off x="6766560" y="4718304"/>
+            <a:ext cx="365760" cy="329184"/>
           </a:xfrm>
           <a:prstGeom prst="rect">
             <a:avLst/>
@@ -6527,7 +6527,7 @@
               </a:lnSpc>
             </a:pPr>
             <a:r>
-              <a:rPr sz="1400" b="0">
+              <a:rPr sz="1300" b="0">
                 <a:solidFill>
                   <a:srgbClr val="059669"/>
                 </a:solidFill>
@@ -6546,8 +6546,8 @@
         </p:nvSpPr>
         <p:spPr>
           <a:xfrm>
-            <a:off x="7132320" y="4910328"/>
-            <a:ext cx="3474720" cy="365760"/>
+            <a:off x="7132320" y="4718304"/>
+            <a:ext cx="3474720" cy="329184"/>
           </a:xfrm>
           <a:prstGeom prst="rect">
             <a:avLst/>
@@ -6566,7 +6566,7 @@
               </a:lnSpc>
             </a:pPr>
             <a:r>
-              <a:rPr sz="1250" b="0">
+              <a:rPr sz="1200" b="0">
                 <a:solidFill>
                   <a:srgbClr val="1C1736"/>
                 </a:solidFill>
@@ -6585,8 +6585,8 @@
         </p:nvSpPr>
         <p:spPr>
           <a:xfrm>
-            <a:off x="10607040" y="4910328"/>
-            <a:ext cx="777240" cy="365760"/>
+            <a:off x="10607040" y="4718304"/>
+            <a:ext cx="777240" cy="329184"/>
           </a:xfrm>
           <a:prstGeom prst="rect">
             <a:avLst/>
@@ -6605,7 +6605,7 @@
               </a:lnSpc>
             </a:pPr>
             <a:r>
-              <a:rPr sz="1400" b="0">
+              <a:rPr sz="1300" b="0">
                 <a:solidFill>
                   <a:srgbClr val="6D28D9"/>
                 </a:solidFill>
@@ -6624,8 +6624,8 @@
         </p:nvSpPr>
         <p:spPr>
           <a:xfrm>
-            <a:off x="6766560" y="5303520"/>
-            <a:ext cx="365760" cy="365760"/>
+            <a:off x="6766560" y="5056631"/>
+            <a:ext cx="365760" cy="329184"/>
           </a:xfrm>
           <a:prstGeom prst="rect">
             <a:avLst/>
@@ -6644,7 +6644,7 @@
               </a:lnSpc>
             </a:pPr>
             <a:r>
-              <a:rPr sz="1400" b="0">
+              <a:rPr sz="1300" b="0">
                 <a:solidFill>
                   <a:srgbClr val="059669"/>
                 </a:solidFill>
@@ -6663,8 +6663,8 @@
         </p:nvSpPr>
         <p:spPr>
           <a:xfrm>
-            <a:off x="7132320" y="5303520"/>
-            <a:ext cx="3474720" cy="365760"/>
+            <a:off x="7132320" y="5056631"/>
+            <a:ext cx="3474720" cy="329184"/>
           </a:xfrm>
           <a:prstGeom prst="rect">
             <a:avLst/>
@@ -6683,7 +6683,7 @@
               </a:lnSpc>
             </a:pPr>
             <a:r>
-              <a:rPr sz="1250" b="0">
+              <a:rPr sz="1200" b="0">
                 <a:solidFill>
                   <a:srgbClr val="1C1736"/>
                 </a:solidFill>
@@ -6702,8 +6702,8 @@
         </p:nvSpPr>
         <p:spPr>
           <a:xfrm>
-            <a:off x="10607040" y="5303520"/>
-            <a:ext cx="777240" cy="365760"/>
+            <a:off x="10607040" y="5056631"/>
+            <a:ext cx="777240" cy="329184"/>
           </a:xfrm>
           <a:prstGeom prst="rect">
             <a:avLst/>
@@ -6722,7 +6722,7 @@
               </a:lnSpc>
             </a:pPr>
             <a:r>
-              <a:rPr sz="1400" b="0">
+              <a:rPr sz="1300" b="0">
                 <a:solidFill>
                   <a:srgbClr val="6D28D9"/>
                 </a:solidFill>
@@ -6741,8 +6741,8 @@
         </p:nvSpPr>
         <p:spPr>
           <a:xfrm>
-            <a:off x="6766560" y="5696712"/>
-            <a:ext cx="365760" cy="365760"/>
+            <a:off x="6766560" y="5394960"/>
+            <a:ext cx="365760" cy="329184"/>
           </a:xfrm>
           <a:prstGeom prst="rect">
             <a:avLst/>
@@ -6761,7 +6761,7 @@
               </a:lnSpc>
             </a:pPr>
             <a:r>
-              <a:rPr sz="1400" b="0">
+              <a:rPr sz="1300" b="0">
                 <a:solidFill>
                   <a:srgbClr val="059669"/>
                 </a:solidFill>
@@ -6780,8 +6780,8 @@
         </p:nvSpPr>
         <p:spPr>
           <a:xfrm>
-            <a:off x="7132320" y="5696712"/>
-            <a:ext cx="3474720" cy="365760"/>
+            <a:off x="7132320" y="5394960"/>
+            <a:ext cx="3474720" cy="329184"/>
           </a:xfrm>
           <a:prstGeom prst="rect">
             <a:avLst/>
@@ -6800,13 +6800,13 @@
               </a:lnSpc>
             </a:pPr>
             <a:r>
-              <a:rPr sz="1250" b="0">
+              <a:rPr sz="1200" b="0">
                 <a:solidFill>
                   <a:srgbClr val="1C1736"/>
                 </a:solidFill>
                 <a:latin typeface="Segoe UI"/>
               </a:rPr>
-              <a:t>MCP stdio client</a:t>
+              <a:t>History, sessions, sign-up and sign-in</a:t>
             </a:r>
           </a:p>
         </p:txBody>
@@ -6819,8 +6819,8 @@
         </p:nvSpPr>
         <p:spPr>
           <a:xfrm>
-            <a:off x="10607040" y="5696712"/>
-            <a:ext cx="777240" cy="365760"/>
+            <a:off x="10607040" y="5394960"/>
+            <a:ext cx="777240" cy="329184"/>
           </a:xfrm>
           <a:prstGeom prst="rect">
             <a:avLst/>
@@ -6839,7 +6839,124 @@
               </a:lnSpc>
             </a:pPr>
             <a:r>
-              <a:rPr sz="1400" b="0">
+              <a:rPr sz="1300" b="0">
+                <a:solidFill>
+                  <a:srgbClr val="6D28D9"/>
+                </a:solidFill>
+                <a:latin typeface="Segoe UI Semibold"/>
+              </a:rPr>
+              <a:t>7</a:t>
+            </a:r>
+          </a:p>
+        </p:txBody>
+      </p:sp>
+      <p:sp>
+        <p:nvSpPr>
+          <p:cNvPr id="42" name="TextBox 41"/>
+          <p:cNvSpPr txBox="1"/>
+          <p:nvPr/>
+        </p:nvSpPr>
+        <p:spPr>
+          <a:xfrm>
+            <a:off x="6766560" y="5733288"/>
+            <a:ext cx="365760" cy="329184"/>
+          </a:xfrm>
+          <a:prstGeom prst="rect">
+            <a:avLst/>
+          </a:prstGeom>
+          <a:noFill/>
+        </p:spPr>
+        <p:txBody>
+          <a:bodyPr wrap="square" anchor="ctr" lIns="45720" rIns="45720" tIns="27432" bIns="27432">
+            <a:spAutoFit/>
+          </a:bodyPr>
+          <a:lstStyle/>
+          <a:p>
+            <a:pPr algn="l">
+              <a:lnSpc>
+                <a:spcPct val="100000"/>
+              </a:lnSpc>
+            </a:pPr>
+            <a:r>
+              <a:rPr sz="1300" b="0">
+                <a:solidFill>
+                  <a:srgbClr val="059669"/>
+                </a:solidFill>
+                <a:latin typeface="Segoe UI Semibold"/>
+              </a:rPr>
+              <a:t>✓</a:t>
+            </a:r>
+          </a:p>
+        </p:txBody>
+      </p:sp>
+      <p:sp>
+        <p:nvSpPr>
+          <p:cNvPr id="43" name="TextBox 42"/>
+          <p:cNvSpPr txBox="1"/>
+          <p:nvPr/>
+        </p:nvSpPr>
+        <p:spPr>
+          <a:xfrm>
+            <a:off x="7132320" y="5733288"/>
+            <a:ext cx="3474720" cy="329184"/>
+          </a:xfrm>
+          <a:prstGeom prst="rect">
+            <a:avLst/>
+          </a:prstGeom>
+          <a:noFill/>
+        </p:spPr>
+        <p:txBody>
+          <a:bodyPr wrap="square" anchor="ctr" lIns="45720" rIns="45720" tIns="27432" bIns="27432">
+            <a:spAutoFit/>
+          </a:bodyPr>
+          <a:lstStyle/>
+          <a:p>
+            <a:pPr algn="l">
+              <a:lnSpc>
+                <a:spcPct val="100000"/>
+              </a:lnSpc>
+            </a:pPr>
+            <a:r>
+              <a:rPr sz="1200" b="0">
+                <a:solidFill>
+                  <a:srgbClr val="1C1736"/>
+                </a:solidFill>
+                <a:latin typeface="Segoe UI"/>
+              </a:rPr>
+              <a:t>MCP stdio client</a:t>
+            </a:r>
+          </a:p>
+        </p:txBody>
+      </p:sp>
+      <p:sp>
+        <p:nvSpPr>
+          <p:cNvPr id="44" name="TextBox 43"/>
+          <p:cNvSpPr txBox="1"/>
+          <p:nvPr/>
+        </p:nvSpPr>
+        <p:spPr>
+          <a:xfrm>
+            <a:off x="10607040" y="5733288"/>
+            <a:ext cx="777240" cy="329184"/>
+          </a:xfrm>
+          <a:prstGeom prst="rect">
+            <a:avLst/>
+          </a:prstGeom>
+          <a:noFill/>
+        </p:spPr>
+        <p:txBody>
+          <a:bodyPr wrap="square" anchor="ctr" lIns="45720" rIns="45720" tIns="27432" bIns="27432">
+            <a:spAutoFit/>
+          </a:bodyPr>
+          <a:lstStyle/>
+          <a:p>
+            <a:pPr algn="r">
+              <a:lnSpc>
+                <a:spcPct val="100000"/>
+              </a:lnSpc>
+            </a:pPr>
+            <a:r>
+              <a:rPr sz="1300" b="0">
                 <a:solidFill>
                   <a:srgbClr val="6D28D9"/>
                 </a:solidFill>
@@ -7859,7 +7976,7 @@
         </p:nvSpPr>
         <p:spPr>
           <a:xfrm>
-            <a:off x="4480560" y="3749039"/>
+            <a:off x="4480560" y="3456432"/>
             <a:ext cx="365760" cy="457200"/>
           </a:xfrm>
           <a:prstGeom prst="rect">
@@ -7898,7 +8015,7 @@
         </p:nvSpPr>
         <p:spPr>
           <a:xfrm>
-            <a:off x="4892040" y="3749039"/>
+            <a:off x="4892040" y="3456432"/>
             <a:ext cx="2880360" cy="685800"/>
           </a:xfrm>
           <a:prstGeom prst="rect">
@@ -7937,7 +8054,7 @@
         </p:nvSpPr>
         <p:spPr>
           <a:xfrm>
-            <a:off x="4480560" y="4937760"/>
+            <a:off x="4480560" y="4352544"/>
             <a:ext cx="365760" cy="457200"/>
           </a:xfrm>
           <a:prstGeom prst="rect">
@@ -7976,7 +8093,7 @@
         </p:nvSpPr>
         <p:spPr>
           <a:xfrm>
-            <a:off x="4892040" y="4937760"/>
+            <a:off x="4892040" y="4352544"/>
             <a:ext cx="2880360" cy="685800"/>
           </a:xfrm>
           <a:prstGeom prst="rect">
@@ -8009,7 +8126,85 @@
       </p:sp>
       <p:sp>
         <p:nvSpPr>
-          <p:cNvPr id="30" name="Rounded Rectangle 29"/>
+          <p:cNvPr id="30" name="TextBox 29"/>
+          <p:cNvSpPr txBox="1"/>
+          <p:nvPr/>
+        </p:nvSpPr>
+        <p:spPr>
+          <a:xfrm>
+            <a:off x="4480560" y="5248656"/>
+            <a:ext cx="365760" cy="457200"/>
+          </a:xfrm>
+          <a:prstGeom prst="rect">
+            <a:avLst/>
+          </a:prstGeom>
+          <a:noFill/>
+        </p:spPr>
+        <p:txBody>
+          <a:bodyPr wrap="square" anchor="t" lIns="45720" rIns="45720" tIns="27432" bIns="27432">
+            <a:spAutoFit/>
+          </a:bodyPr>
+          <a:lstStyle/>
+          <a:p>
+            <a:pPr algn="l">
+              <a:lnSpc>
+                <a:spcPct val="100000"/>
+              </a:lnSpc>
+            </a:pPr>
+            <a:r>
+              <a:rPr sz="1600" b="0">
+                <a:solidFill>
+                  <a:srgbClr val="D97706"/>
+                </a:solidFill>
+                <a:latin typeface="Segoe UI Semibold"/>
+              </a:rPr>
+              <a:t>!</a:t>
+            </a:r>
+          </a:p>
+        </p:txBody>
+      </p:sp>
+      <p:sp>
+        <p:nvSpPr>
+          <p:cNvPr id="31" name="TextBox 30"/>
+          <p:cNvSpPr txBox="1"/>
+          <p:nvPr/>
+        </p:nvSpPr>
+        <p:spPr>
+          <a:xfrm>
+            <a:off x="4892040" y="5248656"/>
+            <a:ext cx="2880360" cy="685800"/>
+          </a:xfrm>
+          <a:prstGeom prst="rect">
+            <a:avLst/>
+          </a:prstGeom>
+          <a:noFill/>
+        </p:spPr>
+        <p:txBody>
+          <a:bodyPr wrap="square" anchor="t" lIns="45720" rIns="45720" tIns="27432" bIns="27432">
+            <a:spAutoFit/>
+          </a:bodyPr>
+          <a:lstStyle/>
+          <a:p>
+            <a:pPr algn="l">
+              <a:lnSpc>
+                <a:spcPct val="100000"/>
+              </a:lnSpc>
+            </a:pPr>
+            <a:r>
+              <a:rPr sz="1400" b="0">
+                <a:solidFill>
+                  <a:srgbClr val="1C1736"/>
+                </a:solidFill>
+                <a:latin typeface="Segoe UI"/>
+              </a:rPr>
+              <a:t>Demo DB reset left a stale login ("Audit not found"): on-disk DB and session check</a:t>
+            </a:r>
+          </a:p>
+        </p:txBody>
+      </p:sp>
+      <p:sp>
+        <p:nvSpPr>
+          <p:cNvPr id="32" name="Rounded Rectangle 31"/>
           <p:cNvSpPr/>
           <p:nvPr/>
         </p:nvSpPr>
@@ -8057,7 +8252,7 @@
       </p:sp>
       <p:sp>
         <p:nvSpPr>
-          <p:cNvPr id="31" name="Rounded Rectangle 30"/>
+          <p:cNvPr id="33" name="Rounded Rectangle 32"/>
           <p:cNvSpPr/>
           <p:nvPr/>
         </p:nvSpPr>
@@ -8103,7 +8298,7 @@
       </p:sp>
       <p:sp>
         <p:nvSpPr>
-          <p:cNvPr id="32" name="TextBox 31"/>
+          <p:cNvPr id="34" name="TextBox 33"/>
           <p:cNvSpPr txBox="1"/>
           <p:nvPr/>
         </p:nvSpPr>
@@ -8142,7 +8337,7 @@
       </p:sp>
       <p:sp>
         <p:nvSpPr>
-          <p:cNvPr id="33" name="Rounded Rectangle 32"/>
+          <p:cNvPr id="35" name="Rounded Rectangle 34"/>
           <p:cNvSpPr/>
           <p:nvPr/>
         </p:nvSpPr>
@@ -8188,7 +8383,7 @@
       </p:sp>
       <p:sp>
         <p:nvSpPr>
-          <p:cNvPr id="34" name="TextBox 33"/>
+          <p:cNvPr id="36" name="TextBox 35"/>
           <p:cNvSpPr txBox="1"/>
           <p:nvPr/>
         </p:nvSpPr>
@@ -8227,7 +8422,7 @@
       </p:sp>
       <p:sp>
         <p:nvSpPr>
-          <p:cNvPr id="35" name="TextBox 34"/>
+          <p:cNvPr id="37" name="TextBox 36"/>
           <p:cNvSpPr txBox="1"/>
           <p:nvPr/>
         </p:nvSpPr>
@@ -8266,7 +8461,7 @@
       </p:sp>
       <p:sp>
         <p:nvSpPr>
-          <p:cNvPr id="36" name="Rounded Rectangle 35"/>
+          <p:cNvPr id="38" name="Rounded Rectangle 37"/>
           <p:cNvSpPr/>
           <p:nvPr/>
         </p:nvSpPr>
@@ -8312,7 +8507,7 @@
       </p:sp>
       <p:sp>
         <p:nvSpPr>
-          <p:cNvPr id="37" name="TextBox 36"/>
+          <p:cNvPr id="39" name="TextBox 38"/>
           <p:cNvSpPr txBox="1"/>
           <p:nvPr/>
         </p:nvSpPr>
@@ -8351,7 +8546,7 @@
       </p:sp>
       <p:sp>
         <p:nvSpPr>
-          <p:cNvPr id="38" name="TextBox 37"/>
+          <p:cNvPr id="40" name="TextBox 39"/>
           <p:cNvSpPr txBox="1"/>
           <p:nvPr/>
         </p:nvSpPr>
@@ -8390,7 +8585,7 @@
       </p:sp>
       <p:sp>
         <p:nvSpPr>
-          <p:cNvPr id="39" name="Rounded Rectangle 38"/>
+          <p:cNvPr id="41" name="Rounded Rectangle 40"/>
           <p:cNvSpPr/>
           <p:nvPr/>
         </p:nvSpPr>
@@ -8436,7 +8631,7 @@
       </p:sp>
       <p:sp>
         <p:nvSpPr>
-          <p:cNvPr id="40" name="TextBox 39"/>
+          <p:cNvPr id="42" name="TextBox 41"/>
           <p:cNvSpPr txBox="1"/>
           <p:nvPr/>
         </p:nvSpPr>
@@ -8475,7 +8670,7 @@
       </p:sp>
       <p:sp>
         <p:nvSpPr>
-          <p:cNvPr id="41" name="TextBox 40"/>
+          <p:cNvPr id="43" name="TextBox 42"/>
           <p:cNvSpPr txBox="1"/>
           <p:nvPr/>
         </p:nvSpPr>
@@ -8514,7 +8709,7 @@
       </p:sp>
       <p:sp>
         <p:nvSpPr>
-          <p:cNvPr id="42" name="Rounded Rectangle 41"/>
+          <p:cNvPr id="44" name="Rounded Rectangle 43"/>
           <p:cNvSpPr/>
           <p:nvPr/>
         </p:nvSpPr>
@@ -8560,7 +8755,7 @@
       </p:sp>
       <p:sp>
         <p:nvSpPr>
-          <p:cNvPr id="43" name="TextBox 42"/>
+          <p:cNvPr id="45" name="TextBox 44"/>
           <p:cNvSpPr txBox="1"/>
           <p:nvPr/>
         </p:nvSpPr>
@@ -8599,7 +8794,7 @@
       </p:sp>
       <p:sp>
         <p:nvSpPr>
-          <p:cNvPr id="44" name="TextBox 43"/>
+          <p:cNvPr id="46" name="TextBox 45"/>
           <p:cNvSpPr txBox="1"/>
           <p:nvPr/>
         </p:nvSpPr>
@@ -8638,7 +8833,7 @@
       </p:sp>
       <p:sp>
         <p:nvSpPr>
-          <p:cNvPr id="45" name="Rounded Rectangle 44"/>
+          <p:cNvPr id="47" name="Rounded Rectangle 46"/>
           <p:cNvSpPr/>
           <p:nvPr/>
         </p:nvSpPr>
@@ -8684,7 +8879,7 @@
       </p:sp>
       <p:sp>
         <p:nvSpPr>
-          <p:cNvPr id="46" name="TextBox 45"/>
+          <p:cNvPr id="48" name="TextBox 47"/>
           <p:cNvSpPr txBox="1"/>
           <p:nvPr/>
         </p:nvSpPr>
@@ -8723,7 +8918,7 @@
       </p:sp>
       <p:sp>
         <p:nvSpPr>
-          <p:cNvPr id="47" name="TextBox 46"/>
+          <p:cNvPr id="49" name="TextBox 48"/>
           <p:cNvSpPr txBox="1"/>
           <p:nvPr/>
         </p:nvSpPr>
@@ -12335,7 +12530,7 @@
                 </a:solidFill>
                 <a:latin typeface="Segoe UI"/>
               </a:rPr>
-              <a:t>Everything runs locally: no paid or cloud AI APIs. 79 automated tests cover the server.</a:t>
+              <a:t>Everything runs locally: no paid or cloud AI APIs. 86 automated tests cover the server.</a:t>
             </a:r>
           </a:p>
         </p:txBody>
@@ -13742,7 +13937,7 @@
                 </a:solidFill>
                 <a:latin typeface="Segoe UI"/>
               </a:rPr>
-              <a:t>79 automated tests</a:t>
+              <a:t>86 automated tests</a:t>
             </a:r>
           </a:p>
         </p:txBody>
@@ -20147,7 +20342,7 @@
         <p:spPr>
           <a:xfrm>
             <a:off x="640080" y="5998464"/>
-            <a:ext cx="2084831" cy="365760"/>
+            <a:ext cx="1755648" cy="365760"/>
           </a:xfrm>
           <a:prstGeom prst="roundRect">
             <a:avLst>
@@ -20192,8 +20387,8 @@
         </p:nvSpPr>
         <p:spPr>
           <a:xfrm>
-            <a:off x="713231" y="5998464"/>
-            <a:ext cx="1965960" cy="365760"/>
+            <a:off x="694944" y="5998464"/>
+            <a:ext cx="1691640" cy="365760"/>
           </a:xfrm>
           <a:prstGeom prst="rect">
             <a:avLst/>
@@ -20212,7 +20407,7 @@
               </a:lnSpc>
             </a:pPr>
             <a:r>
-              <a:rPr sz="1250" b="0">
+              <a:rPr sz="1100" b="0">
                 <a:solidFill>
                   <a:srgbClr val="1C1736"/>
                 </a:solidFill>
@@ -20231,8 +20426,8 @@
         </p:nvSpPr>
         <p:spPr>
           <a:xfrm>
-            <a:off x="2834639" y="5998464"/>
-            <a:ext cx="2084831" cy="365760"/>
+            <a:off x="2468880" y="5998464"/>
+            <a:ext cx="1755648" cy="365760"/>
           </a:xfrm>
           <a:prstGeom prst="roundRect">
             <a:avLst>
@@ -20277,8 +20472,8 @@
         </p:nvSpPr>
         <p:spPr>
           <a:xfrm>
-            <a:off x="2907791" y="5998464"/>
-            <a:ext cx="1965960" cy="365760"/>
+            <a:off x="2523744" y="5998464"/>
+            <a:ext cx="1691640" cy="365760"/>
           </a:xfrm>
           <a:prstGeom prst="rect">
             <a:avLst/>
@@ -20297,7 +20492,7 @@
               </a:lnSpc>
             </a:pPr>
             <a:r>
-              <a:rPr sz="1250" b="0">
+              <a:rPr sz="1100" b="0">
                 <a:solidFill>
                   <a:srgbClr val="1C1736"/>
                 </a:solidFill>
@@ -20316,8 +20511,8 @@
         </p:nvSpPr>
         <p:spPr>
           <a:xfrm>
-            <a:off x="5029200" y="5998464"/>
-            <a:ext cx="2084831" cy="365760"/>
+            <a:off x="4297680" y="5998464"/>
+            <a:ext cx="1755648" cy="365760"/>
           </a:xfrm>
           <a:prstGeom prst="roundRect">
             <a:avLst>
@@ -20362,8 +20557,8 @@
         </p:nvSpPr>
         <p:spPr>
           <a:xfrm>
-            <a:off x="5102352" y="5998464"/>
-            <a:ext cx="1965960" cy="365760"/>
+            <a:off x="4352544" y="5998464"/>
+            <a:ext cx="1691640" cy="365760"/>
           </a:xfrm>
           <a:prstGeom prst="rect">
             <a:avLst/>
@@ -20382,7 +20577,7 @@
               </a:lnSpc>
             </a:pPr>
             <a:r>
-              <a:rPr sz="1250" b="0">
+              <a:rPr sz="1100" b="0">
                 <a:solidFill>
                   <a:srgbClr val="1C1736"/>
                 </a:solidFill>
@@ -20401,8 +20596,93 @@
         </p:nvSpPr>
         <p:spPr>
           <a:xfrm>
-            <a:off x="7223759" y="5998464"/>
-            <a:ext cx="2084831" cy="365760"/>
+            <a:off x="6126480" y="5998464"/>
+            <a:ext cx="1755648" cy="365760"/>
+          </a:xfrm>
+          <a:prstGeom prst="roundRect">
+            <a:avLst>
+              <a:gd name="adj" fmla="val 30000"/>
+            </a:avLst>
+          </a:prstGeom>
+          <a:solidFill>
+            <a:srgbClr val="FFE4E6"/>
+          </a:solidFill>
+          <a:ln>
+            <a:noFill/>
+          </a:ln>
+          <a:effectLst/>
+        </p:spPr>
+        <p:style>
+          <a:lnRef idx="1">
+            <a:schemeClr val="accent1"/>
+          </a:lnRef>
+          <a:fillRef idx="3">
+            <a:schemeClr val="accent1"/>
+          </a:fillRef>
+          <a:effectRef idx="2">
+            <a:schemeClr val="accent1"/>
+          </a:effectRef>
+          <a:fontRef idx="minor">
+            <a:schemeClr val="lt1"/>
+          </a:fontRef>
+        </p:style>
+        <p:txBody>
+          <a:bodyPr rtlCol="0" anchor="ctr"/>
+          <a:lstStyle/>
+          <a:p>
+            <a:pPr algn="ctr"/>
+          </a:p>
+        </p:txBody>
+      </p:sp>
+      <p:sp>
+        <p:nvSpPr>
+          <p:cNvPr id="24" name="TextBox 23"/>
+          <p:cNvSpPr txBox="1"/>
+          <p:nvPr/>
+        </p:nvSpPr>
+        <p:spPr>
+          <a:xfrm>
+            <a:off x="6181344" y="5998464"/>
+            <a:ext cx="1691640" cy="365760"/>
+          </a:xfrm>
+          <a:prstGeom prst="rect">
+            <a:avLst/>
+          </a:prstGeom>
+          <a:noFill/>
+        </p:spPr>
+        <p:txBody>
+          <a:bodyPr wrap="square" anchor="ctr" lIns="45720" rIns="45720" tIns="27432" bIns="27432">
+            <a:spAutoFit/>
+          </a:bodyPr>
+          <a:lstStyle/>
+          <a:p>
+            <a:pPr algn="l">
+              <a:lnSpc>
+                <a:spcPct val="100000"/>
+              </a:lnSpc>
+            </a:pPr>
+            <a:r>
+              <a:rPr sz="1100" b="0">
+                <a:solidFill>
+                  <a:srgbClr val="1C1736"/>
+                </a:solidFill>
+                <a:latin typeface="Segoe UI Semibold"/>
+              </a:rPr>
+              <a:t>04  History + sign-in</a:t>
+            </a:r>
+          </a:p>
+        </p:txBody>
+      </p:sp>
+      <p:sp>
+        <p:nvSpPr>
+          <p:cNvPr id="25" name="Rounded Rectangle 24"/>
+          <p:cNvSpPr/>
+          <p:nvPr/>
+        </p:nvSpPr>
+        <p:spPr>
+          <a:xfrm>
+            <a:off x="7955279" y="5998464"/>
+            <a:ext cx="1755648" cy="365760"/>
           </a:xfrm>
           <a:prstGeom prst="roundRect">
             <a:avLst>
@@ -20441,14 +20721,14 @@
       </p:sp>
       <p:sp>
         <p:nvSpPr>
-          <p:cNvPr id="24" name="TextBox 23"/>
+          <p:cNvPr id="26" name="TextBox 25"/>
           <p:cNvSpPr txBox="1"/>
           <p:nvPr/>
         </p:nvSpPr>
         <p:spPr>
           <a:xfrm>
-            <a:off x="7296912" y="5998464"/>
-            <a:ext cx="1965960" cy="365760"/>
+            <a:off x="8010144" y="5998464"/>
+            <a:ext cx="1691640" cy="365760"/>
           </a:xfrm>
           <a:prstGeom prst="rect">
             <a:avLst/>
@@ -20467,27 +20747,27 @@
               </a:lnSpc>
             </a:pPr>
             <a:r>
-              <a:rPr sz="1250" b="0">
+              <a:rPr sz="1100" b="0">
                 <a:solidFill>
                   <a:srgbClr val="1C1736"/>
                 </a:solidFill>
                 <a:latin typeface="Segoe UI Semibold"/>
               </a:rPr>
-              <a:t>04  Scheduled audits</a:t>
-            </a:r>
-          </a:p>
-        </p:txBody>
-      </p:sp>
-      <p:sp>
-        <p:nvSpPr>
-          <p:cNvPr id="25" name="Rounded Rectangle 24"/>
+              <a:t>05  Scheduled audits</a:t>
+            </a:r>
+          </a:p>
+        </p:txBody>
+      </p:sp>
+      <p:sp>
+        <p:nvSpPr>
+          <p:cNvPr id="27" name="Rounded Rectangle 26"/>
           <p:cNvSpPr/>
           <p:nvPr/>
         </p:nvSpPr>
         <p:spPr>
           <a:xfrm>
-            <a:off x="9418319" y="5998464"/>
-            <a:ext cx="2084831" cy="365760"/>
+            <a:off x="9784080" y="5998464"/>
+            <a:ext cx="1755648" cy="365760"/>
           </a:xfrm>
           <a:prstGeom prst="roundRect">
             <a:avLst>
@@ -20526,14 +20806,14 @@
       </p:sp>
       <p:sp>
         <p:nvSpPr>
-          <p:cNvPr id="26" name="TextBox 25"/>
+          <p:cNvPr id="28" name="TextBox 27"/>
           <p:cNvSpPr txBox="1"/>
           <p:nvPr/>
         </p:nvSpPr>
         <p:spPr>
           <a:xfrm>
-            <a:off x="9491472" y="5998464"/>
-            <a:ext cx="1965960" cy="365760"/>
+            <a:off x="9838944" y="5998464"/>
+            <a:ext cx="1691640" cy="365760"/>
           </a:xfrm>
           <a:prstGeom prst="rect">
             <a:avLst/>
@@ -20552,13 +20832,13 @@
               </a:lnSpc>
             </a:pPr>
             <a:r>
-              <a:rPr sz="1250" b="0">
+              <a:rPr sz="1100" b="0">
                 <a:solidFill>
                   <a:srgbClr val="1C1736"/>
                 </a:solidFill>
                 <a:latin typeface="Segoe UI Semibold"/>
               </a:rPr>
-              <a:t>05  JS rendering</a:t>
+              <a:t>06  JS rendering</a:t>
             </a:r>
           </a:p>
         </p:txBody>

</xml_diff>

<commit_message>
Deck, screenshots and docs for site audits: 4-up feature slide, 102 tests, site crawl in QA_PREP and DEMO_SCRIPT
Co-Authored-By: Claude Sonnet 5.5 <noreply@anthropic.com>
</commit_message>
<xml_diff>
--- a/AuditPilot_IT2_Presentation.pptx
+++ b/AuditPilot_IT2_Presentation.pptx
@@ -608,7 +608,7 @@
           </a:p>
           <a:p>
             <a:r>
-              <a:t>Testing mein 86 tests hain aur sab pass hote hain: 19 checker aur scoring, 21 SSRF, 10 API aur auth, 18 agent, 8 nayi features ke (render, schedule, short refs), 7 history aur sign-in ke, aur 3 MCP ke.</a:t>
+              <a:t>Testing mein 102 tests hain aur sab pass hote hain: 19 checker aur scoring, 21 SSRF, 10 API aur auth, 18 agent, 8 nayi features ke (render, schedule, short refs), 7 history aur sign-in ke, 16 site crawl ke (robots.txt, same-origin, cross-page checks, aggregate score), aur 3 MCP ke.</a:t>
             </a:r>
           </a:p>
           <a:p>
@@ -693,12 +693,12 @@
           </a:p>
           <a:p>
             <a:r>
-              <a:t>Local model CPU par slow hai, isliye summary background mein, queue, aur server start par auto warm-up. JavaScript se bane pages ke liye optional headless render add kiya.</a:t>
-            </a:r>
-          </a:p>
-          <a:p>
-            <a:r>
-              <a:t>Future: bada ya fine-tuned model, docs par RAG, email alerts, CI integration, aur zyada checks.</a:t>
+              <a:t>Local model CPU par slow hai, isliye summary background mein, queue, aur server start par auto warm-up. JavaScript se bane pages ke liye optional headless render add kiya, aur poori site crawl robots.txt, same-origin aur SSRF guard ke saath safe banaya.</a:t>
+            </a:r>
+          </a:p>
+          <a:p>
+            <a:r>
+              <a:t>Future: bada ya fine-tuned model, docs par RAG, email alerts, CI integration, sitemap se crawl seed karna, aur zyada checks.</a:t>
             </a:r>
           </a:p>
         </p:txBody>
@@ -1033,7 +1033,7 @@
           </a:p>
           <a:p>
             <a:r>
-              <a:t>MCP SDK se same tools Claude Code mein bhi chalte hain, aur Vitest se 86 tests likhe hain.</a:t>
+              <a:t>MCP SDK se same tools Claude Code mein bhi chalte hain, aur Vitest se 102 tests likhe hain.</a:t>
             </a:r>
           </a:p>
         </p:txBody>
@@ -1373,7 +1373,12 @@
           </a:p>
           <a:p>
             <a:r>
-              <a:t>Neeche chhe modules hain: audit engine, AI summary aur chat, compare aur trend, history aur sign-in, scheduled audits, aur JavaScript rendering.</a:t>
+              <a:t>Chautha screenshot poori website ka crawl hai: demo site ke 7 pages, site score 77, aur cross-page findings jaise duplicate titles aur broken link.</a:t>
+            </a:r>
+          </a:p>
+          <a:p>
+            <a:r>
+              <a:t>Neeche saat modules hain: audit engine, AI summary aur chat, compare aur trend, history aur sign-in, scheduled audits, JavaScript rendering, aur site crawl.</a:t>
             </a:r>
           </a:p>
         </p:txBody>
@@ -6056,7 +6061,7 @@
                 </a:solidFill>
                 <a:latin typeface="Segoe UI Semibold"/>
               </a:rPr>
-              <a:t>86 / 86</a:t>
+              <a:t>102 / 102</a:t>
             </a:r>
           </a:p>
         </p:txBody>
@@ -6157,7 +6162,7 @@
         <p:spPr>
           <a:xfrm>
             <a:off x="6766560" y="3703320"/>
-            <a:ext cx="365760" cy="329184"/>
+            <a:ext cx="365760" cy="301752"/>
           </a:xfrm>
           <a:prstGeom prst="rect">
             <a:avLst/>
@@ -6196,7 +6201,7 @@
         <p:spPr>
           <a:xfrm>
             <a:off x="7132320" y="3703320"/>
-            <a:ext cx="3474720" cy="329184"/>
+            <a:ext cx="3474720" cy="301752"/>
           </a:xfrm>
           <a:prstGeom prst="rect">
             <a:avLst/>
@@ -6235,7 +6240,7 @@
         <p:spPr>
           <a:xfrm>
             <a:off x="10607040" y="3703320"/>
-            <a:ext cx="777240" cy="329184"/>
+            <a:ext cx="777240" cy="301752"/>
           </a:xfrm>
           <a:prstGeom prst="rect">
             <a:avLst/>
@@ -6273,8 +6278,8 @@
         </p:nvSpPr>
         <p:spPr>
           <a:xfrm>
-            <a:off x="6766560" y="4041648"/>
-            <a:ext cx="365760" cy="329184"/>
+            <a:off x="6766560" y="4009644"/>
+            <a:ext cx="365760" cy="301752"/>
           </a:xfrm>
           <a:prstGeom prst="rect">
             <a:avLst/>
@@ -6312,8 +6317,8 @@
         </p:nvSpPr>
         <p:spPr>
           <a:xfrm>
-            <a:off x="7132320" y="4041648"/>
-            <a:ext cx="3474720" cy="329184"/>
+            <a:off x="7132320" y="4009644"/>
+            <a:ext cx="3474720" cy="301752"/>
           </a:xfrm>
           <a:prstGeom prst="rect">
             <a:avLst/>
@@ -6351,8 +6356,8 @@
         </p:nvSpPr>
         <p:spPr>
           <a:xfrm>
-            <a:off x="10607040" y="4041648"/>
-            <a:ext cx="777240" cy="329184"/>
+            <a:off x="10607040" y="4009644"/>
+            <a:ext cx="777240" cy="301752"/>
           </a:xfrm>
           <a:prstGeom prst="rect">
             <a:avLst/>
@@ -6390,8 +6395,8 @@
         </p:nvSpPr>
         <p:spPr>
           <a:xfrm>
-            <a:off x="6766560" y="4379976"/>
-            <a:ext cx="365760" cy="329184"/>
+            <a:off x="6766560" y="4315968"/>
+            <a:ext cx="365760" cy="301752"/>
           </a:xfrm>
           <a:prstGeom prst="rect">
             <a:avLst/>
@@ -6429,8 +6434,8 @@
         </p:nvSpPr>
         <p:spPr>
           <a:xfrm>
-            <a:off x="7132320" y="4379976"/>
-            <a:ext cx="3474720" cy="329184"/>
+            <a:off x="7132320" y="4315968"/>
+            <a:ext cx="3474720" cy="301752"/>
           </a:xfrm>
           <a:prstGeom prst="rect">
             <a:avLst/>
@@ -6468,8 +6473,8 @@
         </p:nvSpPr>
         <p:spPr>
           <a:xfrm>
-            <a:off x="10607040" y="4379976"/>
-            <a:ext cx="777240" cy="329184"/>
+            <a:off x="10607040" y="4315968"/>
+            <a:ext cx="777240" cy="301752"/>
           </a:xfrm>
           <a:prstGeom prst="rect">
             <a:avLst/>
@@ -6507,8 +6512,8 @@
         </p:nvSpPr>
         <p:spPr>
           <a:xfrm>
-            <a:off x="6766560" y="4718304"/>
-            <a:ext cx="365760" cy="329184"/>
+            <a:off x="6766560" y="4622292"/>
+            <a:ext cx="365760" cy="301752"/>
           </a:xfrm>
           <a:prstGeom prst="rect">
             <a:avLst/>
@@ -6546,8 +6551,8 @@
         </p:nvSpPr>
         <p:spPr>
           <a:xfrm>
-            <a:off x="7132320" y="4718304"/>
-            <a:ext cx="3474720" cy="329184"/>
+            <a:off x="7132320" y="4622292"/>
+            <a:ext cx="3474720" cy="301752"/>
           </a:xfrm>
           <a:prstGeom prst="rect">
             <a:avLst/>
@@ -6585,8 +6590,8 @@
         </p:nvSpPr>
         <p:spPr>
           <a:xfrm>
-            <a:off x="10607040" y="4718304"/>
-            <a:ext cx="777240" cy="329184"/>
+            <a:off x="10607040" y="4622292"/>
+            <a:ext cx="777240" cy="301752"/>
           </a:xfrm>
           <a:prstGeom prst="rect">
             <a:avLst/>
@@ -6624,8 +6629,8 @@
         </p:nvSpPr>
         <p:spPr>
           <a:xfrm>
-            <a:off x="6766560" y="5056631"/>
-            <a:ext cx="365760" cy="329184"/>
+            <a:off x="6766560" y="4928616"/>
+            <a:ext cx="365760" cy="301752"/>
           </a:xfrm>
           <a:prstGeom prst="rect">
             <a:avLst/>
@@ -6663,8 +6668,8 @@
         </p:nvSpPr>
         <p:spPr>
           <a:xfrm>
-            <a:off x="7132320" y="5056631"/>
-            <a:ext cx="3474720" cy="329184"/>
+            <a:off x="7132320" y="4928616"/>
+            <a:ext cx="3474720" cy="301752"/>
           </a:xfrm>
           <a:prstGeom prst="rect">
             <a:avLst/>
@@ -6702,8 +6707,8 @@
         </p:nvSpPr>
         <p:spPr>
           <a:xfrm>
-            <a:off x="10607040" y="5056631"/>
-            <a:ext cx="777240" cy="329184"/>
+            <a:off x="10607040" y="4928616"/>
+            <a:ext cx="777240" cy="301752"/>
           </a:xfrm>
           <a:prstGeom prst="rect">
             <a:avLst/>
@@ -6741,8 +6746,8 @@
         </p:nvSpPr>
         <p:spPr>
           <a:xfrm>
-            <a:off x="6766560" y="5394960"/>
-            <a:ext cx="365760" cy="329184"/>
+            <a:off x="6766560" y="5234940"/>
+            <a:ext cx="365760" cy="301752"/>
           </a:xfrm>
           <a:prstGeom prst="rect">
             <a:avLst/>
@@ -6780,8 +6785,8 @@
         </p:nvSpPr>
         <p:spPr>
           <a:xfrm>
-            <a:off x="7132320" y="5394960"/>
-            <a:ext cx="3474720" cy="329184"/>
+            <a:off x="7132320" y="5234940"/>
+            <a:ext cx="3474720" cy="301752"/>
           </a:xfrm>
           <a:prstGeom prst="rect">
             <a:avLst/>
@@ -6819,8 +6824,8 @@
         </p:nvSpPr>
         <p:spPr>
           <a:xfrm>
-            <a:off x="10607040" y="5394960"/>
-            <a:ext cx="777240" cy="329184"/>
+            <a:off x="10607040" y="5234940"/>
+            <a:ext cx="777240" cy="301752"/>
           </a:xfrm>
           <a:prstGeom prst="rect">
             <a:avLst/>
@@ -6858,8 +6863,8 @@
         </p:nvSpPr>
         <p:spPr>
           <a:xfrm>
-            <a:off x="6766560" y="5733288"/>
-            <a:ext cx="365760" cy="329184"/>
+            <a:off x="6766560" y="5541264"/>
+            <a:ext cx="365760" cy="301752"/>
           </a:xfrm>
           <a:prstGeom prst="rect">
             <a:avLst/>
@@ -6897,8 +6902,8 @@
         </p:nvSpPr>
         <p:spPr>
           <a:xfrm>
-            <a:off x="7132320" y="5733288"/>
-            <a:ext cx="3474720" cy="329184"/>
+            <a:off x="7132320" y="5541264"/>
+            <a:ext cx="3474720" cy="301752"/>
           </a:xfrm>
           <a:prstGeom prst="rect">
             <a:avLst/>
@@ -6923,7 +6928,7 @@
                 </a:solidFill>
                 <a:latin typeface="Segoe UI"/>
               </a:rPr>
-              <a:t>MCP stdio client</a:t>
+              <a:t>Site crawl, robots.txt, cross-page checks</a:t>
             </a:r>
           </a:p>
         </p:txBody>
@@ -6936,8 +6941,125 @@
         </p:nvSpPr>
         <p:spPr>
           <a:xfrm>
-            <a:off x="10607040" y="5733288"/>
-            <a:ext cx="777240" cy="329184"/>
+            <a:off x="10607040" y="5541264"/>
+            <a:ext cx="777240" cy="301752"/>
+          </a:xfrm>
+          <a:prstGeom prst="rect">
+            <a:avLst/>
+          </a:prstGeom>
+          <a:noFill/>
+        </p:spPr>
+        <p:txBody>
+          <a:bodyPr wrap="square" anchor="ctr" lIns="45720" rIns="45720" tIns="27432" bIns="27432">
+            <a:spAutoFit/>
+          </a:bodyPr>
+          <a:lstStyle/>
+          <a:p>
+            <a:pPr algn="r">
+              <a:lnSpc>
+                <a:spcPct val="100000"/>
+              </a:lnSpc>
+            </a:pPr>
+            <a:r>
+              <a:rPr sz="1300" b="0">
+                <a:solidFill>
+                  <a:srgbClr val="6D28D9"/>
+                </a:solidFill>
+                <a:latin typeface="Segoe UI Semibold"/>
+              </a:rPr>
+              <a:t>16</a:t>
+            </a:r>
+          </a:p>
+        </p:txBody>
+      </p:sp>
+      <p:sp>
+        <p:nvSpPr>
+          <p:cNvPr id="45" name="TextBox 44"/>
+          <p:cNvSpPr txBox="1"/>
+          <p:nvPr/>
+        </p:nvSpPr>
+        <p:spPr>
+          <a:xfrm>
+            <a:off x="6766560" y="5847588"/>
+            <a:ext cx="365760" cy="301752"/>
+          </a:xfrm>
+          <a:prstGeom prst="rect">
+            <a:avLst/>
+          </a:prstGeom>
+          <a:noFill/>
+        </p:spPr>
+        <p:txBody>
+          <a:bodyPr wrap="square" anchor="ctr" lIns="45720" rIns="45720" tIns="27432" bIns="27432">
+            <a:spAutoFit/>
+          </a:bodyPr>
+          <a:lstStyle/>
+          <a:p>
+            <a:pPr algn="l">
+              <a:lnSpc>
+                <a:spcPct val="100000"/>
+              </a:lnSpc>
+            </a:pPr>
+            <a:r>
+              <a:rPr sz="1300" b="0">
+                <a:solidFill>
+                  <a:srgbClr val="059669"/>
+                </a:solidFill>
+                <a:latin typeface="Segoe UI Semibold"/>
+              </a:rPr>
+              <a:t>✓</a:t>
+            </a:r>
+          </a:p>
+        </p:txBody>
+      </p:sp>
+      <p:sp>
+        <p:nvSpPr>
+          <p:cNvPr id="46" name="TextBox 45"/>
+          <p:cNvSpPr txBox="1"/>
+          <p:nvPr/>
+        </p:nvSpPr>
+        <p:spPr>
+          <a:xfrm>
+            <a:off x="7132320" y="5847588"/>
+            <a:ext cx="3474720" cy="301752"/>
+          </a:xfrm>
+          <a:prstGeom prst="rect">
+            <a:avLst/>
+          </a:prstGeom>
+          <a:noFill/>
+        </p:spPr>
+        <p:txBody>
+          <a:bodyPr wrap="square" anchor="ctr" lIns="45720" rIns="45720" tIns="27432" bIns="27432">
+            <a:spAutoFit/>
+          </a:bodyPr>
+          <a:lstStyle/>
+          <a:p>
+            <a:pPr algn="l">
+              <a:lnSpc>
+                <a:spcPct val="100000"/>
+              </a:lnSpc>
+            </a:pPr>
+            <a:r>
+              <a:rPr sz="1200" b="0">
+                <a:solidFill>
+                  <a:srgbClr val="1C1736"/>
+                </a:solidFill>
+                <a:latin typeface="Segoe UI"/>
+              </a:rPr>
+              <a:t>MCP stdio client</a:t>
+            </a:r>
+          </a:p>
+        </p:txBody>
+      </p:sp>
+      <p:sp>
+        <p:nvSpPr>
+          <p:cNvPr id="47" name="TextBox 46"/>
+          <p:cNvSpPr txBox="1"/>
+          <p:nvPr/>
+        </p:nvSpPr>
+        <p:spPr>
+          <a:xfrm>
+            <a:off x="10607040" y="5847588"/>
+            <a:ext cx="777240" cy="301752"/>
           </a:xfrm>
           <a:prstGeom prst="rect">
             <a:avLst/>
@@ -8119,7 +8241,7 @@
                 </a:solidFill>
                 <a:latin typeface="Segoe UI"/>
               </a:rPr>
-              <a:t>JavaScript-built pages: optional headless render, SSRF-guarded</a:t>
+              <a:t>Crawling a site safely: robots.txt, same-origin only, SSRF-guarded</a:t>
             </a:r>
           </a:p>
         </p:txBody>
@@ -8950,7 +9072,7 @@
                 </a:solidFill>
                 <a:latin typeface="Segoe UI"/>
               </a:rPr>
-              <a:t>More checks and Lighthouse-style metrics</a:t>
+              <a:t>Sitemap seeding and Lighthouse-style metrics</a:t>
             </a:r>
           </a:p>
         </p:txBody>
@@ -12530,7 +12652,7 @@
                 </a:solidFill>
                 <a:latin typeface="Segoe UI"/>
               </a:rPr>
-              <a:t>Everything runs locally: no paid or cloud AI APIs. 86 automated tests cover the server.</a:t>
+              <a:t>Everything runs locally: no paid or cloud AI APIs. 102 automated tests cover the server.</a:t>
             </a:r>
           </a:p>
         </p:txBody>
@@ -13937,7 +14059,7 @@
                 </a:solidFill>
                 <a:latin typeface="Segoe UI"/>
               </a:rPr>
-              <a:t>86 automated tests</a:t>
+              <a:t>102 automated tests</a:t>
             </a:r>
           </a:p>
         </p:txBody>
@@ -19956,7 +20078,7 @@
                 </a:solidFill>
                 <a:latin typeface="Segoe UI"/>
               </a:rPr>
-              <a:t>Screenshots are real captures of the running app auditing https://nikshey.xyz with the local model (qwen2.5:3b).</a:t>
+              <a:t>Screenshots are real captures of the running app with the local model (qwen2.5:3b): https://nikshey.xyz and the /demo/site crawl.</a:t>
             </a:r>
           </a:p>
         </p:txBody>
@@ -20008,8 +20130,8 @@
         </p:nvSpPr>
         <p:spPr>
           <a:xfrm>
-            <a:off x="640080" y="1645920"/>
-            <a:ext cx="6309360" cy="4114800"/>
+            <a:off x="640080" y="1600200"/>
+            <a:ext cx="5394960" cy="2057400"/>
           </a:xfrm>
           <a:prstGeom prst="roundRect">
             <a:avLst>
@@ -20064,8 +20186,8 @@
         </p:blipFill>
         <p:spPr>
           <a:xfrm>
-            <a:off x="704088" y="1709928"/>
-            <a:ext cx="6181344" cy="3483864"/>
+            <a:off x="713231" y="1673352"/>
+            <a:ext cx="3438144" cy="1911095"/>
           </a:xfrm>
           <a:prstGeom prst="rect">
             <a:avLst/>
@@ -20080,8 +20202,8 @@
         </p:nvSpPr>
         <p:spPr>
           <a:xfrm>
-            <a:off x="731519" y="5212080"/>
-            <a:ext cx="6126480" cy="502920"/>
+            <a:off x="4251960" y="1691640"/>
+            <a:ext cx="1737360" cy="1874519"/>
           </a:xfrm>
           <a:prstGeom prst="rect">
             <a:avLst/>
@@ -20100,13 +20222,32 @@
               </a:lnSpc>
             </a:pPr>
             <a:r>
-              <a:rPr sz="1250" b="0">
+              <a:rPr sz="1400" b="0">
                 <a:solidFill>
                   <a:srgbClr val="1C1736"/>
                 </a:solidFill>
                 <a:latin typeface="Segoe UI Semibold"/>
               </a:rPr>
-              <a:t>Real audit of nikshey.xyz: score 79, category scores, AI summary</a:t>
+              <a:t>Audit report</a:t>
+            </a:r>
+          </a:p>
+          <a:p>
+            <a:pPr algn="l">
+              <a:lnSpc>
+                <a:spcPct val="100000"/>
+              </a:lnSpc>
+              <a:spcBef>
+                <a:spcPts val="495"/>
+              </a:spcBef>
+            </a:pPr>
+            <a:r>
+              <a:rPr sz="1100" b="0">
+                <a:solidFill>
+                  <a:srgbClr val="6B6788"/>
+                </a:solidFill>
+                <a:latin typeface="Segoe UI"/>
+              </a:rPr>
+              <a:t>nikshey.xyz scored 79: gauge, category scores and the AI summary</a:t>
             </a:r>
           </a:p>
         </p:txBody>
@@ -20119,8 +20260,8 @@
         </p:nvSpPr>
         <p:spPr>
           <a:xfrm>
-            <a:off x="7178040" y="1645920"/>
-            <a:ext cx="4370832" cy="2194560"/>
+            <a:off x="6172200" y="1600200"/>
+            <a:ext cx="5394960" cy="2057400"/>
           </a:xfrm>
           <a:prstGeom prst="roundRect">
             <a:avLst>
@@ -20175,8 +20316,8 @@
         </p:blipFill>
         <p:spPr>
           <a:xfrm>
-            <a:off x="7242048" y="1709928"/>
-            <a:ext cx="4242816" cy="1563624"/>
+            <a:off x="6245352" y="1673352"/>
+            <a:ext cx="3438144" cy="1911095"/>
           </a:xfrm>
           <a:prstGeom prst="rect">
             <a:avLst/>
@@ -20191,8 +20332,8 @@
         </p:nvSpPr>
         <p:spPr>
           <a:xfrm>
-            <a:off x="7269479" y="3291840"/>
-            <a:ext cx="4187952" cy="502920"/>
+            <a:off x="9784080" y="1691640"/>
+            <a:ext cx="1737360" cy="1874519"/>
           </a:xfrm>
           <a:prstGeom prst="rect">
             <a:avLst/>
@@ -20211,13 +20352,32 @@
               </a:lnSpc>
             </a:pPr>
             <a:r>
-              <a:rPr sz="1250" b="0">
+              <a:rPr sz="1400" b="0">
                 <a:solidFill>
                   <a:srgbClr val="1C1736"/>
                 </a:solidFill>
                 <a:latin typeface="Segoe UI Semibold"/>
               </a:rPr>
-              <a:t>Evidence and a ready fix snippet per finding</a:t>
+              <a:t>Evidence and fix</a:t>
+            </a:r>
+          </a:p>
+          <a:p>
+            <a:pPr algn="l">
+              <a:lnSpc>
+                <a:spcPct val="100000"/>
+              </a:lnSpc>
+              <a:spcBef>
+                <a:spcPts val="495"/>
+              </a:spcBef>
+            </a:pPr>
+            <a:r>
+              <a:rPr sz="1100" b="0">
+                <a:solidFill>
+                  <a:srgbClr val="6B6788"/>
+                </a:solidFill>
+                <a:latin typeface="Segoe UI"/>
+              </a:rPr>
+              <a:t>Every finding shows its evidence and a ready fix snippet</a:t>
             </a:r>
           </a:p>
         </p:txBody>
@@ -20230,8 +20390,8 @@
         </p:nvSpPr>
         <p:spPr>
           <a:xfrm>
-            <a:off x="7178040" y="3749039"/>
-            <a:ext cx="4370832" cy="2194560"/>
+            <a:off x="640080" y="3749039"/>
+            <a:ext cx="5394960" cy="2057400"/>
           </a:xfrm>
           <a:prstGeom prst="roundRect">
             <a:avLst>
@@ -20286,8 +20446,8 @@
         </p:blipFill>
         <p:spPr>
           <a:xfrm>
-            <a:off x="7242048" y="3813048"/>
-            <a:ext cx="4242816" cy="1563624"/>
+            <a:off x="713231" y="3822191"/>
+            <a:ext cx="3438144" cy="1911095"/>
           </a:xfrm>
           <a:prstGeom prst="rect">
             <a:avLst/>
@@ -20302,8 +20462,8 @@
         </p:nvSpPr>
         <p:spPr>
           <a:xfrm>
-            <a:off x="7269479" y="5394959"/>
-            <a:ext cx="4187952" cy="502920"/>
+            <a:off x="4251960" y="3840479"/>
+            <a:ext cx="1737360" cy="1874519"/>
           </a:xfrm>
           <a:prstGeom prst="rect">
             <a:avLst/>
@@ -20322,13 +20482,32 @@
               </a:lnSpc>
             </a:pPr>
             <a:r>
-              <a:rPr sz="1250" b="0">
+              <a:rPr sz="1400" b="0">
                 <a:solidFill>
                   <a:srgbClr val="1C1736"/>
                 </a:solidFill>
                 <a:latin typeface="Segoe UI Semibold"/>
               </a:rPr>
-              <a:t>Agent chat with a collapsible tool trace</a:t>
+              <a:t>Agent chat</a:t>
+            </a:r>
+          </a:p>
+          <a:p>
+            <a:pPr algn="l">
+              <a:lnSpc>
+                <a:spcPct val="100000"/>
+              </a:lnSpc>
+              <a:spcBef>
+                <a:spcPts val="495"/>
+              </a:spcBef>
+            </a:pPr>
+            <a:r>
+              <a:rPr sz="1100" b="0">
+                <a:solidFill>
+                  <a:srgbClr val="6B6788"/>
+                </a:solidFill>
+                <a:latin typeface="Segoe UI"/>
+              </a:rPr>
+              <a:t>A collapsible tool trace shows the tool, its arguments and the time</a:t>
             </a:r>
           </a:p>
         </p:txBody>
@@ -20341,8 +20520,138 @@
         </p:nvSpPr>
         <p:spPr>
           <a:xfrm>
+            <a:off x="6172200" y="3749039"/>
+            <a:ext cx="5394960" cy="2057400"/>
+          </a:xfrm>
+          <a:prstGeom prst="roundRect">
+            <a:avLst>
+              <a:gd name="adj" fmla="val 3000"/>
+            </a:avLst>
+          </a:prstGeom>
+          <a:solidFill>
+            <a:srgbClr val="FFFFFF"/>
+          </a:solidFill>
+          <a:ln w="12700">
+            <a:solidFill>
+              <a:srgbClr val="E6E2F3"/>
+            </a:solidFill>
+          </a:ln>
+          <a:effectLst/>
+        </p:spPr>
+        <p:style>
+          <a:lnRef idx="1">
+            <a:schemeClr val="accent1"/>
+          </a:lnRef>
+          <a:fillRef idx="3">
+            <a:schemeClr val="accent1"/>
+          </a:fillRef>
+          <a:effectRef idx="2">
+            <a:schemeClr val="accent1"/>
+          </a:effectRef>
+          <a:fontRef idx="minor">
+            <a:schemeClr val="lt1"/>
+          </a:fontRef>
+        </p:style>
+        <p:txBody>
+          <a:bodyPr rtlCol="0" anchor="ctr"/>
+          <a:lstStyle/>
+          <a:p>
+            <a:pPr algn="ctr"/>
+          </a:p>
+        </p:txBody>
+      </p:sp>
+      <p:pic>
+        <p:nvPicPr>
+          <p:cNvPr id="18" name="Picture 17" descr="e.png"/>
+          <p:cNvPicPr>
+            <a:picLocks noChangeAspect="1"/>
+          </p:cNvPicPr>
+          <p:nvPr/>
+        </p:nvPicPr>
+        <p:blipFill>
+          <a:blip r:embed="rId6"/>
+          <a:stretch>
+            <a:fillRect/>
+          </a:stretch>
+        </p:blipFill>
+        <p:spPr>
+          <a:xfrm>
+            <a:off x="6245352" y="3822191"/>
+            <a:ext cx="3438144" cy="1911095"/>
+          </a:xfrm>
+          <a:prstGeom prst="rect">
+            <a:avLst/>
+          </a:prstGeom>
+        </p:spPr>
+      </p:pic>
+      <p:sp>
+        <p:nvSpPr>
+          <p:cNvPr id="19" name="TextBox 18"/>
+          <p:cNvSpPr txBox="1"/>
+          <p:nvPr/>
+        </p:nvSpPr>
+        <p:spPr>
+          <a:xfrm>
+            <a:off x="9784080" y="3840479"/>
+            <a:ext cx="1737360" cy="1874519"/>
+          </a:xfrm>
+          <a:prstGeom prst="rect">
+            <a:avLst/>
+          </a:prstGeom>
+          <a:noFill/>
+        </p:spPr>
+        <p:txBody>
+          <a:bodyPr wrap="square" anchor="ctr" lIns="45720" rIns="45720" tIns="27432" bIns="27432">
+            <a:spAutoFit/>
+          </a:bodyPr>
+          <a:lstStyle/>
+          <a:p>
+            <a:pPr algn="l">
+              <a:lnSpc>
+                <a:spcPct val="100000"/>
+              </a:lnSpc>
+            </a:pPr>
+            <a:r>
+              <a:rPr sz="1400" b="0">
+                <a:solidFill>
+                  <a:srgbClr val="1C1736"/>
+                </a:solidFill>
+                <a:latin typeface="Segoe UI Semibold"/>
+              </a:rPr>
+              <a:t>Whole-site audit</a:t>
+            </a:r>
+          </a:p>
+          <a:p>
+            <a:pPr algn="l">
+              <a:lnSpc>
+                <a:spcPct val="100000"/>
+              </a:lnSpc>
+              <a:spcBef>
+                <a:spcPts val="495"/>
+              </a:spcBef>
+            </a:pPr>
+            <a:r>
+              <a:rPr sz="1100" b="0">
+                <a:solidFill>
+                  <a:srgbClr val="6B6788"/>
+                </a:solidFill>
+                <a:latin typeface="Segoe UI"/>
+              </a:rPr>
+              <a:t>/demo/site: 7 pages crawled, site score 77, plus cross-page findings</a:t>
+            </a:r>
+          </a:p>
+        </p:txBody>
+      </p:sp>
+      <p:sp>
+        <p:nvSpPr>
+          <p:cNvPr id="20" name="Rounded Rectangle 19"/>
+          <p:cNvSpPr/>
+          <p:nvPr/>
+        </p:nvSpPr>
+        <p:spPr>
+          <a:xfrm>
             <a:off x="640080" y="5998464"/>
-            <a:ext cx="1755648" cy="365760"/>
+            <a:ext cx="1508760" cy="365760"/>
           </a:xfrm>
           <a:prstGeom prst="roundRect">
             <a:avLst>
@@ -20381,14 +20690,14 @@
       </p:sp>
       <p:sp>
         <p:nvSpPr>
-          <p:cNvPr id="18" name="TextBox 17"/>
+          <p:cNvPr id="21" name="TextBox 20"/>
           <p:cNvSpPr txBox="1"/>
           <p:nvPr/>
         </p:nvSpPr>
         <p:spPr>
           <a:xfrm>
-            <a:off x="694944" y="5998464"/>
-            <a:ext cx="1691640" cy="365760"/>
+            <a:off x="685800" y="5998464"/>
+            <a:ext cx="1463040" cy="365760"/>
           </a:xfrm>
           <a:prstGeom prst="rect">
             <a:avLst/>
@@ -20407,7 +20716,7 @@
               </a:lnSpc>
             </a:pPr>
             <a:r>
-              <a:rPr sz="1100" b="0">
+              <a:rPr sz="1050" b="0">
                 <a:solidFill>
                   <a:srgbClr val="1C1736"/>
                 </a:solidFill>
@@ -20420,14 +20729,14 @@
       </p:sp>
       <p:sp>
         <p:nvSpPr>
-          <p:cNvPr id="19" name="Rounded Rectangle 18"/>
+          <p:cNvPr id="22" name="Rounded Rectangle 21"/>
           <p:cNvSpPr/>
           <p:nvPr/>
         </p:nvSpPr>
         <p:spPr>
           <a:xfrm>
-            <a:off x="2468880" y="5998464"/>
-            <a:ext cx="1755648" cy="365760"/>
+            <a:off x="2203704" y="5998464"/>
+            <a:ext cx="1508760" cy="365760"/>
           </a:xfrm>
           <a:prstGeom prst="roundRect">
             <a:avLst>
@@ -20466,14 +20775,14 @@
       </p:sp>
       <p:sp>
         <p:nvSpPr>
-          <p:cNvPr id="20" name="TextBox 19"/>
+          <p:cNvPr id="23" name="TextBox 22"/>
           <p:cNvSpPr txBox="1"/>
           <p:nvPr/>
         </p:nvSpPr>
         <p:spPr>
           <a:xfrm>
-            <a:off x="2523744" y="5998464"/>
-            <a:ext cx="1691640" cy="365760"/>
+            <a:off x="2249424" y="5998464"/>
+            <a:ext cx="1463040" cy="365760"/>
           </a:xfrm>
           <a:prstGeom prst="rect">
             <a:avLst/>
@@ -20492,27 +20801,27 @@
               </a:lnSpc>
             </a:pPr>
             <a:r>
-              <a:rPr sz="1100" b="0">
+              <a:rPr sz="1050" b="0">
                 <a:solidFill>
                   <a:srgbClr val="1C1736"/>
                 </a:solidFill>
                 <a:latin typeface="Segoe UI Semibold"/>
               </a:rPr>
-              <a:t>02  AI summary + chat</a:t>
-            </a:r>
-          </a:p>
-        </p:txBody>
-      </p:sp>
-      <p:sp>
-        <p:nvSpPr>
-          <p:cNvPr id="21" name="Rounded Rectangle 20"/>
+              <a:t>02  AI + chat</a:t>
+            </a:r>
+          </a:p>
+        </p:txBody>
+      </p:sp>
+      <p:sp>
+        <p:nvSpPr>
+          <p:cNvPr id="24" name="Rounded Rectangle 23"/>
           <p:cNvSpPr/>
           <p:nvPr/>
         </p:nvSpPr>
         <p:spPr>
           <a:xfrm>
-            <a:off x="4297680" y="5998464"/>
-            <a:ext cx="1755648" cy="365760"/>
+            <a:off x="3767328" y="5998464"/>
+            <a:ext cx="1508760" cy="365760"/>
           </a:xfrm>
           <a:prstGeom prst="roundRect">
             <a:avLst>
@@ -20551,14 +20860,14 @@
       </p:sp>
       <p:sp>
         <p:nvSpPr>
-          <p:cNvPr id="22" name="TextBox 21"/>
+          <p:cNvPr id="25" name="TextBox 24"/>
           <p:cNvSpPr txBox="1"/>
           <p:nvPr/>
         </p:nvSpPr>
         <p:spPr>
           <a:xfrm>
-            <a:off x="4352544" y="5998464"/>
-            <a:ext cx="1691640" cy="365760"/>
+            <a:off x="3813048" y="5998464"/>
+            <a:ext cx="1463040" cy="365760"/>
           </a:xfrm>
           <a:prstGeom prst="rect">
             <a:avLst/>
@@ -20577,7 +20886,7 @@
               </a:lnSpc>
             </a:pPr>
             <a:r>
-              <a:rPr sz="1100" b="0">
+              <a:rPr sz="1050" b="0">
                 <a:solidFill>
                   <a:srgbClr val="1C1736"/>
                 </a:solidFill>
@@ -20590,14 +20899,14 @@
       </p:sp>
       <p:sp>
         <p:nvSpPr>
-          <p:cNvPr id="23" name="Rounded Rectangle 22"/>
+          <p:cNvPr id="26" name="Rounded Rectangle 25"/>
           <p:cNvSpPr/>
           <p:nvPr/>
         </p:nvSpPr>
         <p:spPr>
           <a:xfrm>
-            <a:off x="6126480" y="5998464"/>
-            <a:ext cx="1755648" cy="365760"/>
+            <a:off x="5330952" y="5998464"/>
+            <a:ext cx="1508760" cy="365760"/>
           </a:xfrm>
           <a:prstGeom prst="roundRect">
             <a:avLst>
@@ -20636,14 +20945,14 @@
       </p:sp>
       <p:sp>
         <p:nvSpPr>
-          <p:cNvPr id="24" name="TextBox 23"/>
+          <p:cNvPr id="27" name="TextBox 26"/>
           <p:cNvSpPr txBox="1"/>
           <p:nvPr/>
         </p:nvSpPr>
         <p:spPr>
           <a:xfrm>
-            <a:off x="6181344" y="5998464"/>
-            <a:ext cx="1691640" cy="365760"/>
+            <a:off x="5376672" y="5998464"/>
+            <a:ext cx="1463040" cy="365760"/>
           </a:xfrm>
           <a:prstGeom prst="rect">
             <a:avLst/>
@@ -20662,7 +20971,7 @@
               </a:lnSpc>
             </a:pPr>
             <a:r>
-              <a:rPr sz="1100" b="0">
+              <a:rPr sz="1050" b="0">
                 <a:solidFill>
                   <a:srgbClr val="1C1736"/>
                 </a:solidFill>
@@ -20675,14 +20984,14 @@
       </p:sp>
       <p:sp>
         <p:nvSpPr>
-          <p:cNvPr id="25" name="Rounded Rectangle 24"/>
+          <p:cNvPr id="28" name="Rounded Rectangle 27"/>
           <p:cNvSpPr/>
           <p:nvPr/>
         </p:nvSpPr>
         <p:spPr>
           <a:xfrm>
-            <a:off x="7955279" y="5998464"/>
-            <a:ext cx="1755648" cy="365760"/>
+            <a:off x="6894576" y="5998464"/>
+            <a:ext cx="1508760" cy="365760"/>
           </a:xfrm>
           <a:prstGeom prst="roundRect">
             <a:avLst>
@@ -20721,14 +21030,14 @@
       </p:sp>
       <p:sp>
         <p:nvSpPr>
-          <p:cNvPr id="26" name="TextBox 25"/>
+          <p:cNvPr id="29" name="TextBox 28"/>
           <p:cNvSpPr txBox="1"/>
           <p:nvPr/>
         </p:nvSpPr>
         <p:spPr>
           <a:xfrm>
-            <a:off x="8010144" y="5998464"/>
-            <a:ext cx="1691640" cy="365760"/>
+            <a:off x="6940296" y="5998464"/>
+            <a:ext cx="1463040" cy="365760"/>
           </a:xfrm>
           <a:prstGeom prst="rect">
             <a:avLst/>
@@ -20747,27 +21056,27 @@
               </a:lnSpc>
             </a:pPr>
             <a:r>
-              <a:rPr sz="1100" b="0">
+              <a:rPr sz="1050" b="0">
                 <a:solidFill>
                   <a:srgbClr val="1C1736"/>
                 </a:solidFill>
                 <a:latin typeface="Segoe UI Semibold"/>
               </a:rPr>
-              <a:t>05  Scheduled audits</a:t>
-            </a:r>
-          </a:p>
-        </p:txBody>
-      </p:sp>
-      <p:sp>
-        <p:nvSpPr>
-          <p:cNvPr id="27" name="Rounded Rectangle 26"/>
+              <a:t>05  Schedules</a:t>
+            </a:r>
+          </a:p>
+        </p:txBody>
+      </p:sp>
+      <p:sp>
+        <p:nvSpPr>
+          <p:cNvPr id="30" name="Rounded Rectangle 29"/>
           <p:cNvSpPr/>
           <p:nvPr/>
         </p:nvSpPr>
         <p:spPr>
           <a:xfrm>
-            <a:off x="9784080" y="5998464"/>
-            <a:ext cx="1755648" cy="365760"/>
+            <a:off x="8458200" y="5998464"/>
+            <a:ext cx="1508760" cy="365760"/>
           </a:xfrm>
           <a:prstGeom prst="roundRect">
             <a:avLst>
@@ -20806,14 +21115,14 @@
       </p:sp>
       <p:sp>
         <p:nvSpPr>
-          <p:cNvPr id="28" name="TextBox 27"/>
+          <p:cNvPr id="31" name="TextBox 30"/>
           <p:cNvSpPr txBox="1"/>
           <p:nvPr/>
         </p:nvSpPr>
         <p:spPr>
           <a:xfrm>
-            <a:off x="9838944" y="5998464"/>
-            <a:ext cx="1691640" cy="365760"/>
+            <a:off x="8503920" y="5998464"/>
+            <a:ext cx="1463040" cy="365760"/>
           </a:xfrm>
           <a:prstGeom prst="rect">
             <a:avLst/>
@@ -20832,13 +21141,98 @@
               </a:lnSpc>
             </a:pPr>
             <a:r>
-              <a:rPr sz="1100" b="0">
+              <a:rPr sz="1050" b="0">
                 <a:solidFill>
                   <a:srgbClr val="1C1736"/>
                 </a:solidFill>
                 <a:latin typeface="Segoe UI Semibold"/>
               </a:rPr>
               <a:t>06  JS rendering</a:t>
+            </a:r>
+          </a:p>
+        </p:txBody>
+      </p:sp>
+      <p:sp>
+        <p:nvSpPr>
+          <p:cNvPr id="32" name="Rounded Rectangle 31"/>
+          <p:cNvSpPr/>
+          <p:nvPr/>
+        </p:nvSpPr>
+        <p:spPr>
+          <a:xfrm>
+            <a:off x="10021824" y="5998464"/>
+            <a:ext cx="1508760" cy="365760"/>
+          </a:xfrm>
+          <a:prstGeom prst="roundRect">
+            <a:avLst>
+              <a:gd name="adj" fmla="val 30000"/>
+            </a:avLst>
+          </a:prstGeom>
+          <a:solidFill>
+            <a:srgbClr val="D1FAE5"/>
+          </a:solidFill>
+          <a:ln>
+            <a:noFill/>
+          </a:ln>
+          <a:effectLst/>
+        </p:spPr>
+        <p:style>
+          <a:lnRef idx="1">
+            <a:schemeClr val="accent1"/>
+          </a:lnRef>
+          <a:fillRef idx="3">
+            <a:schemeClr val="accent1"/>
+          </a:fillRef>
+          <a:effectRef idx="2">
+            <a:schemeClr val="accent1"/>
+          </a:effectRef>
+          <a:fontRef idx="minor">
+            <a:schemeClr val="lt1"/>
+          </a:fontRef>
+        </p:style>
+        <p:txBody>
+          <a:bodyPr rtlCol="0" anchor="ctr"/>
+          <a:lstStyle/>
+          <a:p>
+            <a:pPr algn="ctr"/>
+          </a:p>
+        </p:txBody>
+      </p:sp>
+      <p:sp>
+        <p:nvSpPr>
+          <p:cNvPr id="33" name="TextBox 32"/>
+          <p:cNvSpPr txBox="1"/>
+          <p:nvPr/>
+        </p:nvSpPr>
+        <p:spPr>
+          <a:xfrm>
+            <a:off x="10067544" y="5998464"/>
+            <a:ext cx="1463040" cy="365760"/>
+          </a:xfrm>
+          <a:prstGeom prst="rect">
+            <a:avLst/>
+          </a:prstGeom>
+          <a:noFill/>
+        </p:spPr>
+        <p:txBody>
+          <a:bodyPr wrap="square" anchor="ctr" lIns="45720" rIns="45720" tIns="27432" bIns="27432">
+            <a:spAutoFit/>
+          </a:bodyPr>
+          <a:lstStyle/>
+          <a:p>
+            <a:pPr algn="l">
+              <a:lnSpc>
+                <a:spcPct val="100000"/>
+              </a:lnSpc>
+            </a:pPr>
+            <a:r>
+              <a:rPr sz="1050" b="0">
+                <a:solidFill>
+                  <a:srgbClr val="1C1736"/>
+                </a:solidFill>
+                <a:latin typeface="Segoe UI Semibold"/>
+              </a:rPr>
+              <a:t>07  Site crawl</a:t>
             </a:r>
           </a:p>
         </p:txBody>
@@ -22673,6 +23067,25 @@
                 <a:latin typeface="Segoe UI"/>
               </a:rPr>
               <a:t>Chat answer: about 15 to 40 s</a:t>
+            </a:r>
+          </a:p>
+          <a:p>
+            <a:pPr algn="l">
+              <a:lnSpc>
+                <a:spcPct val="100000"/>
+              </a:lnSpc>
+              <a:spcBef>
+                <a:spcPts val="585"/>
+              </a:spcBef>
+            </a:pPr>
+            <a:r>
+              <a:rPr sz="1300" b="0">
+                <a:solidFill>
+                  <a:srgbClr val="1C1736"/>
+                </a:solidFill>
+                <a:latin typeface="Segoe UI"/>
+              </a:rPr>
+              <a:t>Site crawl, 7 demo pages: about 2 s</a:t>
             </a:r>
           </a:p>
           <a:p>

</xml_diff>

<commit_message>
Crawler: seed from /sitemap.xml (same-origin, section-scoped), CRAWL_USE_SITEMAP flag, 2 tests (104 total); deck and docs updated
Co-Authored-By: Claude Sonnet 5.5 <noreply@anthropic.com>
</commit_message>
<xml_diff>
--- a/AuditPilot_IT2_Presentation.pptx
+++ b/AuditPilot_IT2_Presentation.pptx
@@ -608,7 +608,7 @@
           </a:p>
           <a:p>
             <a:r>
-              <a:t>Testing mein 102 tests hain aur sab pass hote hain: 19 checker aur scoring, 21 SSRF, 10 API aur auth, 18 agent, 8 nayi features ke (render, schedule, short refs), 7 history aur sign-in ke, 16 site crawl ke (robots.txt, same-origin, cross-page checks, aggregate score), aur 3 MCP ke.</a:t>
+              <a:t>Testing mein 104 tests hain aur sab pass hote hain: 19 checker aur scoring, 21 SSRF, 10 API aur auth, 18 agent, 8 nayi features ke (render, schedule, short refs), 7 history aur sign-in ke, 18 site crawl ke (robots.txt, same-origin, cross-page checks, aggregate score), aur 3 MCP ke.</a:t>
             </a:r>
           </a:p>
           <a:p>
@@ -693,12 +693,12 @@
           </a:p>
           <a:p>
             <a:r>
-              <a:t>Local model CPU par slow hai, isliye summary background mein, queue, aur server start par auto warm-up. JavaScript se bane pages ke liye optional headless render add kiya, aur poori site crawl robots.txt, same-origin aur SSRF guard ke saath safe banaya.</a:t>
-            </a:r>
-          </a:p>
-          <a:p>
-            <a:r>
-              <a:t>Future: bada ya fine-tuned model, docs par RAG, email alerts, CI integration, sitemap se crawl seed karna, aur zyada checks.</a:t>
+              <a:t>Local model CPU par slow hai, isliye summary background mein, queue, aur server start par auto warm-up. JavaScript se bane pages ke liye optional headless render add kiya, aur poori site crawl robots.txt, sitemap.xml, same-origin aur SSRF guard ke saath safe banaya.</a:t>
+            </a:r>
+          </a:p>
+          <a:p>
+            <a:r>
+              <a:t>Future: bada ya fine-tuned model, docs par RAG, email alerts, CI integration, aur zyada checks.</a:t>
             </a:r>
           </a:p>
         </p:txBody>
@@ -1033,7 +1033,7 @@
           </a:p>
           <a:p>
             <a:r>
-              <a:t>MCP SDK se same tools Claude Code mein bhi chalte hain, aur Vitest se 102 tests likhe hain.</a:t>
+              <a:t>MCP SDK se same tools Claude Code mein bhi chalte hain, aur Vitest se 104 tests likhe hain.</a:t>
             </a:r>
           </a:p>
         </p:txBody>
@@ -6061,7 +6061,7 @@
                 </a:solidFill>
                 <a:latin typeface="Segoe UI Semibold"/>
               </a:rPr>
-              <a:t>102 / 102</a:t>
+              <a:t>104 / 104</a:t>
             </a:r>
           </a:p>
         </p:txBody>
@@ -6967,7 +6967,7 @@
                 </a:solidFill>
                 <a:latin typeface="Segoe UI Semibold"/>
               </a:rPr>
-              <a:t>16</a:t>
+              <a:t>18</a:t>
             </a:r>
           </a:p>
         </p:txBody>
@@ -9072,7 +9072,7 @@
                 </a:solidFill>
                 <a:latin typeface="Segoe UI"/>
               </a:rPr>
-              <a:t>Sitemap seeding and Lighthouse-style metrics</a:t>
+              <a:t>More checks and Lighthouse-style metrics</a:t>
             </a:r>
           </a:p>
         </p:txBody>
@@ -12652,7 +12652,7 @@
                 </a:solidFill>
                 <a:latin typeface="Segoe UI"/>
               </a:rPr>
-              <a:t>Everything runs locally: no paid or cloud AI APIs. 102 automated tests cover the server.</a:t>
+              <a:t>Everything runs locally: no paid or cloud AI APIs. 104 automated tests cover the server.</a:t>
             </a:r>
           </a:p>
         </p:txBody>
@@ -14059,7 +14059,7 @@
                 </a:solidFill>
                 <a:latin typeface="Segoe UI"/>
               </a:rPr>
-              <a:t>102 automated tests</a:t>
+              <a:t>104 automated tests</a:t>
             </a:r>
           </a:p>
         </p:txBody>

</xml_diff>